<commit_message>
Muallif ma'lumoti va nusxa ko'chirishga qarshi choralar
- Prezentatsiya: titul/yakun slaydda va har slayd pastida muallif (Mamadaliyeva Xurshidaxon, Jalaquduq tumani 14-maktab); PDF nusxa
- Ilova: muallif footer, meta, konsol belgisi, LICENSE.md
- protect.js: o'ng tugma, Ctrl+S/U/P/A, F12, DevTools, nusxa olish, sudrash bloklanadi; chop etish bloklanadi
- .vercelignore: docs/ va README saytga chiqmaydi

Co-Authored-By: Claude Fable 5.1 <noreply@anthropic.com>
</commit_message>
<xml_diff>
--- a/docs/TIMSS-masterklass.pptx
+++ b/docs/TIMSS-masterklass.pptx
@@ -2542,7 +2542,7 @@
         </p:nvSpPr>
         <p:spPr>
           <a:xfrm>
-            <a:off x="548640" y="3246120"/>
+            <a:off x="548640" y="3154680"/>
             <a:ext cx="8046720" cy="365760"/>
           </a:xfrm>
           <a:prstGeom prst="rect">
@@ -2575,14 +2575,90 @@
       </p:sp>
       <p:sp>
         <p:nvSpPr>
-          <p:cNvPr id="9" name="Text 6"/>
-          <p:cNvSpPr txBox="1"/>
-          <p:nvPr/>
-        </p:nvSpPr>
-        <p:spPr>
-          <a:xfrm>
-            <a:off x="548640" y="4114800"/>
-            <a:ext cx="8046720" cy="365760"/>
+          <p:cNvPr id="9" name="Shape 6"/>
+          <p:cNvSpPr/>
+          <p:nvPr/>
+        </p:nvSpPr>
+        <p:spPr>
+          <a:xfrm>
+            <a:off x="548640" y="3703320"/>
+            <a:ext cx="5669280" cy="777240"/>
+          </a:xfrm>
+          <a:prstGeom prst="roundRect">
+            <a:avLst>
+              <a:gd name="adj" fmla="val 14118"/>
+            </a:avLst>
+          </a:prstGeom>
+          <a:solidFill>
+            <a:srgbClr val="1C1C3F"/>
+          </a:solidFill>
+          <a:ln w="12700">
+            <a:solidFill>
+              <a:srgbClr val="2A2A55"/>
+            </a:solidFill>
+            <a:prstDash val="solid"/>
+          </a:ln>
+        </p:spPr>
+      </p:sp>
+      <p:sp>
+        <p:nvSpPr>
+          <p:cNvPr id="10" name="Shape 7"/>
+          <p:cNvSpPr/>
+          <p:nvPr/>
+        </p:nvSpPr>
+        <p:spPr>
+          <a:xfrm>
+            <a:off x="685800" y="3822192"/>
+            <a:ext cx="548640" cy="548640"/>
+          </a:xfrm>
+          <a:prstGeom prst="ellipse">
+            <a:avLst/>
+          </a:prstGeom>
+          <a:solidFill>
+            <a:srgbClr val="F59E0B"/>
+          </a:solidFill>
+          <a:ln w="12700">
+            <a:solidFill>
+              <a:srgbClr val="F59E0B"/>
+            </a:solidFill>
+            <a:prstDash val="solid"/>
+          </a:ln>
+        </p:spPr>
+      </p:sp>
+      <p:pic>
+        <p:nvPicPr>
+          <p:cNvPr id="11" name="Image 1" descr="preencoded.png">    </p:cNvPr>
+          <p:cNvPicPr>
+            <a:picLocks noChangeAspect="1"/>
+          </p:cNvPicPr>
+          <p:nvPr/>
+        </p:nvPicPr>
+        <p:blipFill>
+          <a:blip r:embed="rId2"/>
+          <a:stretch>
+            <a:fillRect/>
+          </a:stretch>
+        </p:blipFill>
+        <p:spPr>
+          <a:xfrm>
+            <a:off x="828446" y="3964838"/>
+            <a:ext cx="263347" cy="263347"/>
+          </a:xfrm>
+          <a:prstGeom prst="rect">
+            <a:avLst/>
+          </a:prstGeom>
+        </p:spPr>
+      </p:pic>
+      <p:sp>
+        <p:nvSpPr>
+          <p:cNvPr id="12" name="Text 8"/>
+          <p:cNvSpPr txBox="1"/>
+          <p:nvPr/>
+        </p:nvSpPr>
+        <p:spPr>
+          <a:xfrm>
+            <a:off x="1371600" y="3749040"/>
+            <a:ext cx="4754880" cy="365760"/>
           </a:xfrm>
           <a:prstGeom prst="rect">
             <a:avLst/>
@@ -2598,7 +2674,85 @@
               <a:buNone/>
             </a:pPr>
             <a:r>
-              <a:rPr lang="en-US" sz="1300" dirty="0">
+              <a:rPr lang="en-US" sz="1700" b="1" dirty="0">
+                <a:solidFill>
+                  <a:srgbClr val="FFFFFF"/>
+                </a:solidFill>
+                <a:latin typeface="Calibri" pitchFamily="34" charset="0"/>
+                <a:ea typeface="Calibri" pitchFamily="34" charset="-122"/>
+                <a:cs typeface="Calibri" pitchFamily="34" charset="-120"/>
+              </a:rPr>
+              <a:t>Mamadaliyeva Xurshidaxon</a:t>
+            </a:r>
+            <a:endParaRPr lang="en-US" sz="1700" dirty="0"/>
+          </a:p>
+        </p:txBody>
+      </p:sp>
+      <p:sp>
+        <p:nvSpPr>
+          <p:cNvPr id="13" name="Text 9"/>
+          <p:cNvSpPr txBox="1"/>
+          <p:nvPr/>
+        </p:nvSpPr>
+        <p:spPr>
+          <a:xfrm>
+            <a:off x="1371600" y="4096512"/>
+            <a:ext cx="4754880" cy="320040"/>
+          </a:xfrm>
+          <a:prstGeom prst="rect">
+            <a:avLst/>
+          </a:prstGeom>
+          <a:noFill/>
+          <a:ln/>
+        </p:spPr>
+        <p:txBody>
+          <a:bodyPr wrap="square" lIns="0" tIns="0" rIns="0" bIns="0" rtlCol="0" anchor="ctr"/>
+          <a:lstStyle/>
+          <a:p>
+            <a:pPr indent="0" marL="0">
+              <a:buNone/>
+            </a:pPr>
+            <a:r>
+              <a:rPr lang="en-US" sz="1200" dirty="0">
+                <a:solidFill>
+                  <a:srgbClr val="B8B8D8"/>
+                </a:solidFill>
+                <a:latin typeface="Calibri" pitchFamily="34" charset="0"/>
+                <a:ea typeface="Calibri" pitchFamily="34" charset="-122"/>
+                <a:cs typeface="Calibri" pitchFamily="34" charset="-120"/>
+              </a:rPr>
+              <a:t>Jalaquduq tumani 14-maktab boshlang'ich sinf o'qituvchisi</a:t>
+            </a:r>
+            <a:endParaRPr lang="en-US" sz="1200" dirty="0"/>
+          </a:p>
+        </p:txBody>
+      </p:sp>
+      <p:sp>
+        <p:nvSpPr>
+          <p:cNvPr id="14" name="Text 10"/>
+          <p:cNvSpPr txBox="1"/>
+          <p:nvPr/>
+        </p:nvSpPr>
+        <p:spPr>
+          <a:xfrm>
+            <a:off x="548640" y="4617720"/>
+            <a:ext cx="8046720" cy="320040"/>
+          </a:xfrm>
+          <a:prstGeom prst="rect">
+            <a:avLst/>
+          </a:prstGeom>
+          <a:noFill/>
+          <a:ln/>
+        </p:spPr>
+        <p:txBody>
+          <a:bodyPr wrap="square" lIns="0" tIns="0" rIns="0" bIns="0" rtlCol="0" anchor="ctr"/>
+          <a:lstStyle/>
+          <a:p>
+            <a:pPr indent="0" marL="0">
+              <a:buNone/>
+            </a:pPr>
+            <a:r>
+              <a:rPr lang="en-US" sz="1200" dirty="0">
                 <a:solidFill>
                   <a:srgbClr val="8A8AB0"/>
                 </a:solidFill>
@@ -2608,7 +2762,7 @@
               </a:rPr>
               <a:t>Interaktiv o'yinlar bilan  ·  «Sehrli Baraban» ilovasi  ·  45 daqiqa</a:t>
             </a:r>
-            <a:endParaRPr lang="en-US" sz="1300" dirty="0"/>
+            <a:endParaRPr lang="en-US" sz="1200" dirty="0"/>
           </a:p>
         </p:txBody>
       </p:sp>
@@ -3632,7 +3786,7 @@
                 <a:ea typeface="Calibri" pitchFamily="34" charset="-122"/>
                 <a:cs typeface="Calibri" pitchFamily="34" charset="-120"/>
               </a:rPr>
-              <a:t>TIMSS masterklass  ·  Sehrli Baraban</a:t>
+              <a:t>© Mamadaliyeva Xurshidaxon  ·  Jalaquduq tumani 14-maktab  ·  TIMSS masterklass</a:t>
             </a:r>
             <a:endParaRPr lang="en-US" sz="1000" dirty="0"/>
           </a:p>
@@ -5052,7 +5206,7 @@
                 <a:ea typeface="Calibri" pitchFamily="34" charset="-122"/>
                 <a:cs typeface="Calibri" pitchFamily="34" charset="-120"/>
               </a:rPr>
-              <a:t>TIMSS masterklass  ·  Sehrli Baraban</a:t>
+              <a:t>© Mamadaliyeva Xurshidaxon  ·  Jalaquduq tumani 14-maktab  ·  TIMSS masterklass</a:t>
             </a:r>
             <a:endParaRPr lang="en-US" sz="1000" dirty="0"/>
           </a:p>
@@ -6120,7 +6274,7 @@
                 <a:ea typeface="Calibri" pitchFamily="34" charset="-122"/>
                 <a:cs typeface="Calibri" pitchFamily="34" charset="-120"/>
               </a:rPr>
-              <a:t>TIMSS masterklass  ·  Sehrli Baraban</a:t>
+              <a:t>© Mamadaliyeva Xurshidaxon  ·  Jalaquduq tumani 14-maktab  ·  TIMSS masterklass</a:t>
             </a:r>
             <a:endParaRPr lang="en-US" sz="1000" dirty="0"/>
           </a:p>
@@ -7030,7 +7184,7 @@
                 <a:ea typeface="Calibri" pitchFamily="34" charset="-122"/>
                 <a:cs typeface="Calibri" pitchFamily="34" charset="-120"/>
               </a:rPr>
-              <a:t>TIMSS masterklass  ·  Sehrli Baraban</a:t>
+              <a:t>© Mamadaliyeva Xurshidaxon  ·  Jalaquduq tumani 14-maktab  ·  TIMSS masterklass</a:t>
             </a:r>
             <a:endParaRPr lang="en-US" sz="1000" dirty="0"/>
           </a:p>
@@ -7218,8 +7372,8 @@
         </p:nvSpPr>
         <p:spPr>
           <a:xfrm>
-            <a:off x="548640" y="2468880"/>
-            <a:ext cx="7863840" cy="1645920"/>
+            <a:off x="548640" y="2423160"/>
+            <a:ext cx="7863840" cy="1417320"/>
           </a:xfrm>
           <a:prstGeom prst="rect">
             <a:avLst/>
@@ -7233,13 +7387,13 @@
           <a:p>
             <a:pPr marL="177800" indent="-177800">
               <a:spcAft>
-                <a:spcPts val="800"/>
+                <a:spcPts val="600"/>
               </a:spcAft>
               <a:buSzPct val="100000"/>
               <a:buChar char="•"/>
             </a:pPr>
             <a:r>
-              <a:rPr lang="en-US" sz="1600" dirty="0">
+              <a:rPr lang="en-US" sz="1500" dirty="0">
                 <a:solidFill>
                   <a:srgbClr val="E4E2F5"/>
                 </a:solidFill>
@@ -7249,18 +7403,18 @@
               </a:rPr>
               <a:t>TIMSS — yodlashni emas, tushunish va qo'llashni o'lchaydi</a:t>
             </a:r>
-            <a:endParaRPr lang="en-US" sz="1600" dirty="0"/>
+            <a:endParaRPr lang="en-US" sz="1500" dirty="0"/>
           </a:p>
           <a:p>
             <a:pPr marL="177800" indent="-177800">
               <a:spcAft>
-                <a:spcPts val="800"/>
+                <a:spcPts val="600"/>
               </a:spcAft>
               <a:buSzPct val="100000"/>
               <a:buChar char="•"/>
             </a:pPr>
             <a:r>
-              <a:rPr lang="en-US" sz="1600" dirty="0">
+              <a:rPr lang="en-US" sz="1500" dirty="0">
                 <a:solidFill>
                   <a:srgbClr val="E4E2F5"/>
                 </a:solidFill>
@@ -7270,18 +7424,18 @@
               </a:rPr>
               <a:t>Har darsda Bilish → Qo'llash → Mulohaza zanjiri</a:t>
             </a:r>
-            <a:endParaRPr lang="en-US" sz="1600" dirty="0"/>
+            <a:endParaRPr lang="en-US" sz="1500" dirty="0"/>
           </a:p>
           <a:p>
             <a:pPr marL="177800" indent="-177800">
               <a:spcAft>
-                <a:spcPts val="800"/>
+                <a:spcPts val="600"/>
               </a:spcAft>
               <a:buSzPct val="100000"/>
               <a:buChar char="•"/>
             </a:pPr>
             <a:r>
-              <a:rPr lang="en-US" sz="1600" dirty="0">
+              <a:rPr lang="en-US" sz="1500" dirty="0">
                 <a:solidFill>
                   <a:srgbClr val="E4E2F5"/>
                 </a:solidFill>
@@ -7291,18 +7445,18 @@
               </a:rPr>
               <a:t>Interaktiv o'yin — o'quvchini jalb qilishning eng oson yo'li</a:t>
             </a:r>
-            <a:endParaRPr lang="en-US" sz="1600" dirty="0"/>
+            <a:endParaRPr lang="en-US" sz="1500" dirty="0"/>
           </a:p>
           <a:p>
             <a:pPr marL="177800" indent="-177800">
               <a:spcAft>
-                <a:spcPts val="800"/>
+                <a:spcPts val="600"/>
               </a:spcAft>
               <a:buSzPct val="100000"/>
               <a:buChar char="•"/>
             </a:pPr>
             <a:r>
-              <a:rPr lang="en-US" sz="1600" dirty="0">
+              <a:rPr lang="en-US" sz="1500" dirty="0">
                 <a:solidFill>
                   <a:srgbClr val="E4E2F5"/>
                 </a:solidFill>
@@ -7312,7 +7466,7 @@
               </a:rPr>
               <a:t>Uyga vazifa: o'z mavzungizdan har sohaga bittadan savol tuzing</a:t>
             </a:r>
-            <a:endParaRPr lang="en-US" sz="1600" dirty="0"/>
+            <a:endParaRPr lang="en-US" sz="1500" dirty="0"/>
           </a:p>
         </p:txBody>
       </p:sp>
@@ -7324,8 +7478,8 @@
         </p:nvSpPr>
         <p:spPr>
           <a:xfrm>
-            <a:off x="548640" y="4251960"/>
-            <a:ext cx="8046720" cy="411480"/>
+            <a:off x="548640" y="3931920"/>
+            <a:ext cx="8046720" cy="365760"/>
           </a:xfrm>
           <a:prstGeom prst="rect">
             <a:avLst/>
@@ -7352,6 +7506,45 @@
               <a:t>E'tiboringiz uchun rahmat!  ·  Savollar?</a:t>
             </a:r>
             <a:endParaRPr lang="en-US" sz="1800" dirty="0"/>
+          </a:p>
+        </p:txBody>
+      </p:sp>
+      <p:sp>
+        <p:nvSpPr>
+          <p:cNvPr id="9" name="Text 6"/>
+          <p:cNvSpPr txBox="1"/>
+          <p:nvPr/>
+        </p:nvSpPr>
+        <p:spPr>
+          <a:xfrm>
+            <a:off x="548640" y="4389120"/>
+            <a:ext cx="8046720" cy="320040"/>
+          </a:xfrm>
+          <a:prstGeom prst="rect">
+            <a:avLst/>
+          </a:prstGeom>
+          <a:noFill/>
+          <a:ln/>
+        </p:spPr>
+        <p:txBody>
+          <a:bodyPr wrap="square" lIns="0" tIns="0" rIns="0" bIns="0" rtlCol="0" anchor="ctr"/>
+          <a:lstStyle/>
+          <a:p>
+            <a:pPr indent="0" marL="0">
+              <a:buNone/>
+            </a:pPr>
+            <a:r>
+              <a:rPr lang="en-US" sz="1200" dirty="0">
+                <a:solidFill>
+                  <a:srgbClr val="8A8AB0"/>
+                </a:solidFill>
+                <a:latin typeface="Calibri" pitchFamily="34" charset="0"/>
+                <a:ea typeface="Calibri" pitchFamily="34" charset="-122"/>
+                <a:cs typeface="Calibri" pitchFamily="34" charset="-120"/>
+              </a:rPr>
+              <a:t>Mamadaliyeva Xurshidaxon  ·  Jalaquduq tumani 14-maktab boshlang'ich sinf o'qituvchisi</a:t>
+            </a:r>
+            <a:endParaRPr lang="en-US" sz="1200" dirty="0"/>
           </a:p>
         </p:txBody>
       </p:sp>
@@ -8131,7 +8324,7 @@
                 <a:ea typeface="Calibri" pitchFamily="34" charset="-122"/>
                 <a:cs typeface="Calibri" pitchFamily="34" charset="-120"/>
               </a:rPr>
-              <a:t>TIMSS masterklass  ·  Sehrli Baraban</a:t>
+              <a:t>© Mamadaliyeva Xurshidaxon  ·  Jalaquduq tumani 14-maktab  ·  TIMSS masterklass</a:t>
             </a:r>
             <a:endParaRPr lang="en-US" sz="1000" dirty="0"/>
           </a:p>
@@ -8951,7 +9144,7 @@
                 <a:ea typeface="Calibri" pitchFamily="34" charset="-122"/>
                 <a:cs typeface="Calibri" pitchFamily="34" charset="-120"/>
               </a:rPr>
-              <a:t>TIMSS masterklass  ·  Sehrli Baraban</a:t>
+              <a:t>© Mamadaliyeva Xurshidaxon  ·  Jalaquduq tumani 14-maktab  ·  TIMSS masterklass</a:t>
             </a:r>
             <a:endParaRPr lang="en-US" sz="1000" dirty="0"/>
           </a:p>
@@ -9841,7 +10034,7 @@
                 <a:ea typeface="Calibri" pitchFamily="34" charset="-122"/>
                 <a:cs typeface="Calibri" pitchFamily="34" charset="-120"/>
               </a:rPr>
-              <a:t>TIMSS masterklass  ·  Sehrli Baraban</a:t>
+              <a:t>© Mamadaliyeva Xurshidaxon  ·  Jalaquduq tumani 14-maktab  ·  TIMSS masterklass</a:t>
             </a:r>
             <a:endParaRPr lang="en-US" sz="1000" dirty="0"/>
           </a:p>
@@ -10335,7 +10528,7 @@
                 <a:ea typeface="Calibri" pitchFamily="34" charset="-122"/>
                 <a:cs typeface="Calibri" pitchFamily="34" charset="-120"/>
               </a:rPr>
-              <a:t>TIMSS masterklass  ·  Sehrli Baraban</a:t>
+              <a:t>© Mamadaliyeva Xurshidaxon  ·  Jalaquduq tumani 14-maktab  ·  TIMSS masterklass</a:t>
             </a:r>
             <a:endParaRPr lang="en-US" sz="1000" dirty="0"/>
           </a:p>
@@ -11037,7 +11230,7 @@
                 <a:ea typeface="Calibri" pitchFamily="34" charset="-122"/>
                 <a:cs typeface="Calibri" pitchFamily="34" charset="-120"/>
               </a:rPr>
-              <a:t>TIMSS masterklass  ·  Sehrli Baraban</a:t>
+              <a:t>© Mamadaliyeva Xurshidaxon  ·  Jalaquduq tumani 14-maktab  ·  TIMSS masterklass</a:t>
             </a:r>
             <a:endParaRPr lang="en-US" sz="1000" dirty="0"/>
           </a:p>
@@ -12200,7 +12393,7 @@
                 <a:ea typeface="Calibri" pitchFamily="34" charset="-122"/>
                 <a:cs typeface="Calibri" pitchFamily="34" charset="-120"/>
               </a:rPr>
-              <a:t>TIMSS masterklass  ·  Sehrli Baraban</a:t>
+              <a:t>© Mamadaliyeva Xurshidaxon  ·  Jalaquduq tumani 14-maktab  ·  TIMSS masterklass</a:t>
             </a:r>
             <a:endParaRPr lang="en-US" sz="1000" dirty="0"/>
           </a:p>
@@ -12680,7 +12873,7 @@
                 <a:ea typeface="Calibri" pitchFamily="34" charset="-122"/>
                 <a:cs typeface="Calibri" pitchFamily="34" charset="-120"/>
               </a:rPr>
-              <a:t>TIMSS masterklass  ·  Sehrli Baraban</a:t>
+              <a:t>© Mamadaliyeva Xurshidaxon  ·  Jalaquduq tumani 14-maktab  ·  TIMSS masterklass</a:t>
             </a:r>
             <a:endParaRPr lang="en-US" sz="1000" dirty="0"/>
           </a:p>
@@ -13364,7 +13557,7 @@
                 <a:ea typeface="Calibri" pitchFamily="34" charset="-122"/>
                 <a:cs typeface="Calibri" pitchFamily="34" charset="-120"/>
               </a:rPr>
-              <a:t>TIMSS masterklass  ·  Sehrli Baraban</a:t>
+              <a:t>© Mamadaliyeva Xurshidaxon  ·  Jalaquduq tumani 14-maktab  ·  TIMSS masterklass</a:t>
             </a:r>
             <a:endParaRPr lang="en-US" sz="1000" dirty="0"/>
           </a:p>

</xml_diff>